<commit_message>
Update PowerPoint themes and sample output
</commit_message>
<xml_diff>
--- a/scripts/includes/theme.pptx
+++ b/scripts/includes/theme.pptx
@@ -212,7 +212,7 @@
           <a:p>
             <a:fld id="{728AA843-2E0F-4143-82E9-3671A2E63393}" type="datetimeFigureOut">
               <a:rPr lang="en-CA" smtClean="0"/>
-              <a:t>2023-11-04</a:t>
+              <a:t>2023-11-10</a:t>
             </a:fld>
             <a:endParaRPr lang="en-CA"/>
           </a:p>
@@ -456,7 +456,7 @@
           <a:p>
             <a:fld id="{D220F1D1-6C19-4F4B-92BA-F04860C94A09}" type="datetimeFigureOut">
               <a:rPr lang="en-CA" smtClean="0"/>
-              <a:t>2023-11-04</a:t>
+              <a:t>2023-11-10</a:t>
             </a:fld>
             <a:endParaRPr lang="en-CA"/>
           </a:p>
@@ -656,7 +656,7 @@
           <a:p>
             <a:fld id="{D220F1D1-6C19-4F4B-92BA-F04860C94A09}" type="datetimeFigureOut">
               <a:rPr lang="en-CA" smtClean="0"/>
-              <a:t>2023-11-04</a:t>
+              <a:t>2023-11-10</a:t>
             </a:fld>
             <a:endParaRPr lang="en-CA"/>
           </a:p>
@@ -866,7 +866,7 @@
           <a:p>
             <a:fld id="{D220F1D1-6C19-4F4B-92BA-F04860C94A09}" type="datetimeFigureOut">
               <a:rPr lang="en-CA" smtClean="0"/>
-              <a:t>2023-11-04</a:t>
+              <a:t>2023-11-10</a:t>
             </a:fld>
             <a:endParaRPr lang="en-CA"/>
           </a:p>
@@ -1073,7 +1073,7 @@
           <a:p>
             <a:fld id="{D220F1D1-6C19-4F4B-92BA-F04860C94A09}" type="datetimeFigureOut">
               <a:rPr lang="en-CA" smtClean="0"/>
-              <a:t>2023-11-04</a:t>
+              <a:t>2023-11-10</a:t>
             </a:fld>
             <a:endParaRPr lang="en-CA"/>
           </a:p>
@@ -1172,7 +1172,7 @@
           </a:bodyPr>
           <a:lstStyle>
             <a:lvl1pPr algn="ctr">
-              <a:defRPr sz="3200"/>
+              <a:defRPr sz="3600"/>
             </a:lvl1pPr>
           </a:lstStyle>
           <a:p>
@@ -1400,7 +1400,7 @@
           <a:p>
             <a:fld id="{D220F1D1-6C19-4F4B-92BA-F04860C94A09}" type="datetimeFigureOut">
               <a:rPr lang="en-CA" smtClean="0"/>
-              <a:t>2023-11-04</a:t>
+              <a:t>2023-11-10</a:t>
             </a:fld>
             <a:endParaRPr lang="en-CA"/>
           </a:p>
@@ -1716,7 +1716,7 @@
           <a:p>
             <a:fld id="{D220F1D1-6C19-4F4B-92BA-F04860C94A09}" type="datetimeFigureOut">
               <a:rPr lang="en-CA" smtClean="0"/>
-              <a:t>2023-11-04</a:t>
+              <a:t>2023-11-10</a:t>
             </a:fld>
             <a:endParaRPr lang="en-CA"/>
           </a:p>
@@ -2141,7 +2141,7 @@
           <a:p>
             <a:fld id="{D220F1D1-6C19-4F4B-92BA-F04860C94A09}" type="datetimeFigureOut">
               <a:rPr lang="en-CA" smtClean="0"/>
-              <a:t>2023-11-04</a:t>
+              <a:t>2023-11-10</a:t>
             </a:fld>
             <a:endParaRPr lang="en-CA"/>
           </a:p>
@@ -2283,7 +2283,7 @@
           <a:p>
             <a:fld id="{D220F1D1-6C19-4F4B-92BA-F04860C94A09}" type="datetimeFigureOut">
               <a:rPr lang="en-CA" smtClean="0"/>
-              <a:t>2023-11-04</a:t>
+              <a:t>2023-11-10</a:t>
             </a:fld>
             <a:endParaRPr lang="en-CA"/>
           </a:p>
@@ -2396,7 +2396,7 @@
           <a:p>
             <a:fld id="{D220F1D1-6C19-4F4B-92BA-F04860C94A09}" type="datetimeFigureOut">
               <a:rPr lang="en-CA" smtClean="0"/>
-              <a:t>2023-11-04</a:t>
+              <a:t>2023-11-10</a:t>
             </a:fld>
             <a:endParaRPr lang="en-CA"/>
           </a:p>
@@ -2709,7 +2709,7 @@
           <a:p>
             <a:fld id="{D220F1D1-6C19-4F4B-92BA-F04860C94A09}" type="datetimeFigureOut">
               <a:rPr lang="en-CA" smtClean="0"/>
-              <a:t>2023-11-04</a:t>
+              <a:t>2023-11-10</a:t>
             </a:fld>
             <a:endParaRPr lang="en-CA"/>
           </a:p>
@@ -2998,7 +2998,7 @@
           <a:p>
             <a:fld id="{D220F1D1-6C19-4F4B-92BA-F04860C94A09}" type="datetimeFigureOut">
               <a:rPr lang="en-CA" smtClean="0"/>
-              <a:t>2023-11-04</a:t>
+              <a:t>2023-11-10</a:t>
             </a:fld>
             <a:endParaRPr lang="en-CA"/>
           </a:p>
@@ -3251,7 +3251,7 @@
           <a:p>
             <a:fld id="{D220F1D1-6C19-4F4B-92BA-F04860C94A09}" type="datetimeFigureOut">
               <a:rPr lang="en-CA" smtClean="0"/>
-              <a:t>2023-11-04</a:t>
+              <a:t>2023-11-10</a:t>
             </a:fld>
             <a:endParaRPr lang="en-CA"/>
           </a:p>

</xml_diff>

<commit_message>
Update themes and sample output
</commit_message>
<xml_diff>
--- a/scripts/includes/theme.pptx
+++ b/scripts/includes/theme.pptx
@@ -212,7 +212,7 @@
           <a:p>
             <a:fld id="{728AA843-2E0F-4143-82E9-3671A2E63393}" type="datetimeFigureOut">
               <a:rPr lang="en-CA" smtClean="0"/>
-              <a:t>2023-11-10</a:t>
+              <a:t>2024-01-07</a:t>
             </a:fld>
             <a:endParaRPr lang="en-CA"/>
           </a:p>
@@ -456,7 +456,7 @@
           <a:p>
             <a:fld id="{D220F1D1-6C19-4F4B-92BA-F04860C94A09}" type="datetimeFigureOut">
               <a:rPr lang="en-CA" smtClean="0"/>
-              <a:t>2023-11-10</a:t>
+              <a:t>2024-01-07</a:t>
             </a:fld>
             <a:endParaRPr lang="en-CA"/>
           </a:p>
@@ -656,7 +656,7 @@
           <a:p>
             <a:fld id="{D220F1D1-6C19-4F4B-92BA-F04860C94A09}" type="datetimeFigureOut">
               <a:rPr lang="en-CA" smtClean="0"/>
-              <a:t>2023-11-10</a:t>
+              <a:t>2024-01-07</a:t>
             </a:fld>
             <a:endParaRPr lang="en-CA"/>
           </a:p>
@@ -866,7 +866,7 @@
           <a:p>
             <a:fld id="{D220F1D1-6C19-4F4B-92BA-F04860C94A09}" type="datetimeFigureOut">
               <a:rPr lang="en-CA" smtClean="0"/>
-              <a:t>2023-11-10</a:t>
+              <a:t>2024-01-07</a:t>
             </a:fld>
             <a:endParaRPr lang="en-CA"/>
           </a:p>
@@ -1073,7 +1073,7 @@
           <a:p>
             <a:fld id="{D220F1D1-6C19-4F4B-92BA-F04860C94A09}" type="datetimeFigureOut">
               <a:rPr lang="en-CA" smtClean="0"/>
-              <a:t>2023-11-10</a:t>
+              <a:t>2024-01-07</a:t>
             </a:fld>
             <a:endParaRPr lang="en-CA"/>
           </a:p>
@@ -1097,7 +1097,7 @@
         </p:nvSpPr>
         <p:spPr>
           <a:xfrm>
-            <a:off x="5410199" y="6357600"/>
+            <a:off x="4038600" y="6357600"/>
             <a:ext cx="4114800" cy="363600"/>
           </a:xfrm>
         </p:spPr>
@@ -1400,7 +1400,7 @@
           <a:p>
             <a:fld id="{D220F1D1-6C19-4F4B-92BA-F04860C94A09}" type="datetimeFigureOut">
               <a:rPr lang="en-CA" smtClean="0"/>
-              <a:t>2023-11-10</a:t>
+              <a:t>2024-01-07</a:t>
             </a:fld>
             <a:endParaRPr lang="en-CA"/>
           </a:p>
@@ -1716,7 +1716,7 @@
           <a:p>
             <a:fld id="{D220F1D1-6C19-4F4B-92BA-F04860C94A09}" type="datetimeFigureOut">
               <a:rPr lang="en-CA" smtClean="0"/>
-              <a:t>2023-11-10</a:t>
+              <a:t>2024-01-07</a:t>
             </a:fld>
             <a:endParaRPr lang="en-CA"/>
           </a:p>
@@ -1740,7 +1740,7 @@
         </p:nvSpPr>
         <p:spPr>
           <a:xfrm>
-            <a:off x="5410198" y="6356791"/>
+            <a:off x="4038600" y="6356789"/>
             <a:ext cx="4114800" cy="365125"/>
           </a:xfrm>
         </p:spPr>
@@ -1843,10 +1843,10 @@
           <a:lstStyle/>
           <a:p>
             <a:r>
-              <a:rPr lang="en-US"/>
+              <a:rPr lang="en-US" dirty="0"/>
               <a:t>Click to edit Master title style</a:t>
             </a:r>
-            <a:endParaRPr lang="en-CA"/>
+            <a:endParaRPr lang="en-CA" dirty="0"/>
           </a:p>
         </p:txBody>
       </p:sp>
@@ -2141,7 +2141,7 @@
           <a:p>
             <a:fld id="{D220F1D1-6C19-4F4B-92BA-F04860C94A09}" type="datetimeFigureOut">
               <a:rPr lang="en-CA" smtClean="0"/>
-              <a:t>2023-11-10</a:t>
+              <a:t>2024-01-07</a:t>
             </a:fld>
             <a:endParaRPr lang="en-CA"/>
           </a:p>
@@ -2253,10 +2253,10 @@
           <a:lstStyle/>
           <a:p>
             <a:r>
-              <a:rPr lang="en-US"/>
+              <a:rPr lang="en-US" dirty="0"/>
               <a:t>Click to edit Master title style</a:t>
             </a:r>
-            <a:endParaRPr lang="en-CA"/>
+            <a:endParaRPr lang="en-CA" dirty="0"/>
           </a:p>
         </p:txBody>
       </p:sp>
@@ -2283,7 +2283,7 @@
           <a:p>
             <a:fld id="{D220F1D1-6C19-4F4B-92BA-F04860C94A09}" type="datetimeFigureOut">
               <a:rPr lang="en-CA" smtClean="0"/>
-              <a:t>2023-11-10</a:t>
+              <a:t>2024-01-07</a:t>
             </a:fld>
             <a:endParaRPr lang="en-CA"/>
           </a:p>
@@ -2396,7 +2396,7 @@
           <a:p>
             <a:fld id="{D220F1D1-6C19-4F4B-92BA-F04860C94A09}" type="datetimeFigureOut">
               <a:rPr lang="en-CA" smtClean="0"/>
-              <a:t>2023-11-10</a:t>
+              <a:t>2024-01-07</a:t>
             </a:fld>
             <a:endParaRPr lang="en-CA"/>
           </a:p>
@@ -2509,18 +2509,20 @@
           </a:xfrm>
         </p:spPr>
         <p:txBody>
-          <a:bodyPr anchor="b"/>
+          <a:bodyPr anchor="b">
+            <a:normAutofit/>
+          </a:bodyPr>
           <a:lstStyle>
             <a:lvl1pPr>
-              <a:defRPr sz="3200"/>
+              <a:defRPr sz="3600"/>
             </a:lvl1pPr>
           </a:lstStyle>
           <a:p>
             <a:r>
-              <a:rPr lang="en-US"/>
+              <a:rPr lang="en-US" dirty="0"/>
               <a:t>Click to edit Master title style</a:t>
             </a:r>
-            <a:endParaRPr lang="en-CA"/>
+            <a:endParaRPr lang="en-CA" dirty="0"/>
           </a:p>
         </p:txBody>
       </p:sp>
@@ -2542,8 +2544,8 @@
         </p:nvSpPr>
         <p:spPr>
           <a:xfrm>
-            <a:off x="5183188" y="987425"/>
-            <a:ext cx="6172200" cy="4873625"/>
+            <a:off x="4772025" y="457200"/>
+            <a:ext cx="6583363" cy="5411787"/>
           </a:xfrm>
         </p:spPr>
         <p:txBody>
@@ -2638,11 +2640,13 @@
           </a:xfrm>
         </p:spPr>
         <p:txBody>
-          <a:bodyPr/>
+          <a:bodyPr>
+            <a:normAutofit/>
+          </a:bodyPr>
           <a:lstStyle>
             <a:lvl1pPr marL="0" indent="0">
               <a:buNone/>
-              <a:defRPr sz="1600"/>
+              <a:defRPr sz="2000"/>
             </a:lvl1pPr>
             <a:lvl2pPr marL="457200" indent="0">
               <a:buNone/>
@@ -2680,7 +2684,7 @@
           <a:p>
             <a:pPr lvl="0"/>
             <a:r>
-              <a:rPr lang="en-US"/>
+              <a:rPr lang="en-US" dirty="0"/>
               <a:t>Click to edit Master text styles</a:t>
             </a:r>
           </a:p>
@@ -2709,7 +2713,7 @@
           <a:p>
             <a:fld id="{D220F1D1-6C19-4F4B-92BA-F04860C94A09}" type="datetimeFigureOut">
               <a:rPr lang="en-CA" smtClean="0"/>
-              <a:t>2023-11-10</a:t>
+              <a:t>2024-01-07</a:t>
             </a:fld>
             <a:endParaRPr lang="en-CA"/>
           </a:p>
@@ -2822,18 +2826,20 @@
           </a:xfrm>
         </p:spPr>
         <p:txBody>
-          <a:bodyPr anchor="b"/>
+          <a:bodyPr anchor="b">
+            <a:normAutofit/>
+          </a:bodyPr>
           <a:lstStyle>
             <a:lvl1pPr>
-              <a:defRPr sz="3200"/>
+              <a:defRPr sz="3600"/>
             </a:lvl1pPr>
           </a:lstStyle>
           <a:p>
             <a:r>
-              <a:rPr lang="en-US"/>
+              <a:rPr lang="en-US" dirty="0"/>
               <a:t>Click to edit Master title style</a:t>
             </a:r>
-            <a:endParaRPr lang="en-CA"/>
+            <a:endParaRPr lang="en-CA" dirty="0"/>
           </a:p>
         </p:txBody>
       </p:sp>
@@ -2931,7 +2937,7 @@
           <a:lstStyle>
             <a:lvl1pPr marL="0" indent="0">
               <a:buNone/>
-              <a:defRPr sz="1600"/>
+              <a:defRPr sz="2000"/>
             </a:lvl1pPr>
             <a:lvl2pPr marL="457200" indent="0">
               <a:buNone/>
@@ -2969,7 +2975,7 @@
           <a:p>
             <a:pPr lvl="0"/>
             <a:r>
-              <a:rPr lang="en-US"/>
+              <a:rPr lang="en-US" dirty="0"/>
               <a:t>Click to edit Master text styles</a:t>
             </a:r>
           </a:p>
@@ -2998,7 +3004,7 @@
           <a:p>
             <a:fld id="{D220F1D1-6C19-4F4B-92BA-F04860C94A09}" type="datetimeFigureOut">
               <a:rPr lang="en-CA" smtClean="0"/>
-              <a:t>2023-11-10</a:t>
+              <a:t>2024-01-07</a:t>
             </a:fld>
             <a:endParaRPr lang="en-CA"/>
           </a:p>
@@ -3022,7 +3028,7 @@
         </p:nvSpPr>
         <p:spPr>
           <a:xfrm>
-            <a:off x="5410994" y="6349221"/>
+            <a:off x="4038600" y="6356350"/>
             <a:ext cx="4114800" cy="365125"/>
           </a:xfrm>
         </p:spPr>
@@ -3251,7 +3257,7 @@
           <a:p>
             <a:fld id="{D220F1D1-6C19-4F4B-92BA-F04860C94A09}" type="datetimeFigureOut">
               <a:rPr lang="en-CA" smtClean="0"/>
-              <a:t>2023-11-10</a:t>
+              <a:t>2024-01-07</a:t>
             </a:fld>
             <a:endParaRPr lang="en-CA"/>
           </a:p>

</xml_diff>

<commit_message>
Improve PPTX merge workflow and docs
</commit_message>
<xml_diff>
--- a/scripts/includes/theme.pptx
+++ b/scripts/includes/theme.pptx
@@ -1,12 +1,9 @@
 
 <file path=ppt/presentation.xml><?xml version="1.0" encoding="utf-8"?>
-<p:presentation xmlns:a="http://schemas.openxmlformats.org/drawingml/2006/main" xmlns:r="http://schemas.openxmlformats.org/officeDocument/2006/relationships" xmlns:p="http://schemas.openxmlformats.org/presentationml/2006/main" saveSubsetFonts="1" autoCompressPictures="0">
+<p:presentation xmlns:a="http://schemas.openxmlformats.org/drawingml/2006/main" xmlns:r="http://schemas.openxmlformats.org/officeDocument/2006/relationships" xmlns:p="http://schemas.openxmlformats.org/presentationml/2006/main" xmlns:p15="http://schemas.microsoft.com/office/powerpoint/2012/main" saveSubsetFonts="1" autoCompressPictures="0">
   <p:sldMasterIdLst>
     <p:sldMasterId id="2147483750" r:id="rId1"/>
   </p:sldMasterIdLst>
-  <p:handoutMasterIdLst>
-    <p:handoutMasterId r:id="rId3"/>
-  </p:handoutMasterIdLst>
   <p:sldIdLst>
     <p:sldId id="256" r:id="rId2"/>
   </p:sldIdLst>
@@ -17,7 +14,7 @@
       <a:defRPr lang="en-US"/>
     </a:defPPr>
     <a:lvl1pPr marL="0" algn="l" defTabSz="914400" rtl="0" eaLnBrk="1" latinLnBrk="0" hangingPunct="1">
-      <a:defRPr sz="1800" kern="1200">
+      <a:defRPr sz="1600" kern="1200">
         <a:solidFill>
           <a:schemeClr val="tx1"/>
         </a:solidFill>
@@ -27,7 +24,7 @@
       </a:defRPr>
     </a:lvl1pPr>
     <a:lvl2pPr marL="457200" algn="l" defTabSz="914400" rtl="0" eaLnBrk="1" latinLnBrk="0" hangingPunct="1">
-      <a:defRPr sz="1800" kern="1200">
+      <a:defRPr sz="1600" kern="1200">
         <a:solidFill>
           <a:schemeClr val="tx1"/>
         </a:solidFill>
@@ -37,7 +34,7 @@
       </a:defRPr>
     </a:lvl2pPr>
     <a:lvl3pPr marL="914400" algn="l" defTabSz="914400" rtl="0" eaLnBrk="1" latinLnBrk="0" hangingPunct="1">
-      <a:defRPr sz="1800" kern="1200">
+      <a:defRPr sz="1600" kern="1200">
         <a:solidFill>
           <a:schemeClr val="tx1"/>
         </a:solidFill>
@@ -47,7 +44,7 @@
       </a:defRPr>
     </a:lvl3pPr>
     <a:lvl4pPr marL="1371600" algn="l" defTabSz="914400" rtl="0" eaLnBrk="1" latinLnBrk="0" hangingPunct="1">
-      <a:defRPr sz="1800" kern="1200">
+      <a:defRPr sz="1600" kern="1200">
         <a:solidFill>
           <a:schemeClr val="tx1"/>
         </a:solidFill>
@@ -57,7 +54,7 @@
       </a:defRPr>
     </a:lvl4pPr>
     <a:lvl5pPr marL="1828800" algn="l" defTabSz="914400" rtl="0" eaLnBrk="1" latinLnBrk="0" hangingPunct="1">
-      <a:defRPr sz="1800" kern="1200">
+      <a:defRPr sz="1600" kern="1200">
         <a:solidFill>
           <a:schemeClr val="tx1"/>
         </a:solidFill>
@@ -67,7 +64,7 @@
       </a:defRPr>
     </a:lvl5pPr>
     <a:lvl6pPr marL="2286000" algn="l" defTabSz="914400" rtl="0" eaLnBrk="1" latinLnBrk="0" hangingPunct="1">
-      <a:defRPr sz="1800" kern="1200">
+      <a:defRPr sz="1600" kern="1200">
         <a:solidFill>
           <a:schemeClr val="tx1"/>
         </a:solidFill>
@@ -77,7 +74,7 @@
       </a:defRPr>
     </a:lvl6pPr>
     <a:lvl7pPr marL="2743200" algn="l" defTabSz="914400" rtl="0" eaLnBrk="1" latinLnBrk="0" hangingPunct="1">
-      <a:defRPr sz="1800" kern="1200">
+      <a:defRPr sz="1600" kern="1200">
         <a:solidFill>
           <a:schemeClr val="tx1"/>
         </a:solidFill>
@@ -87,7 +84,7 @@
       </a:defRPr>
     </a:lvl7pPr>
     <a:lvl8pPr marL="3200400" algn="l" defTabSz="914400" rtl="0" eaLnBrk="1" latinLnBrk="0" hangingPunct="1">
-      <a:defRPr sz="1800" kern="1200">
+      <a:defRPr sz="1600" kern="1200">
         <a:solidFill>
           <a:schemeClr val="tx1"/>
         </a:solidFill>
@@ -97,7 +94,7 @@
       </a:defRPr>
     </a:lvl8pPr>
     <a:lvl9pPr marL="3657600" algn="l" defTabSz="914400" rtl="0" eaLnBrk="1" latinLnBrk="0" hangingPunct="1">
-      <a:defRPr sz="1800" kern="1200">
+      <a:defRPr sz="1600" kern="1200">
         <a:solidFill>
           <a:schemeClr val="tx1"/>
         </a:solidFill>
@@ -109,202 +106,13 @@
   </p:defaultTextStyle>
   <p:extLst>
     <p:ext uri="{EFAFB233-063F-42B5-8137-9DF3F51BA10A}">
-      <p15:sldGuideLst xmlns:p15="http://schemas.microsoft.com/office/powerpoint/2012/main"/>
+      <p15:sldGuideLst/>
     </p:ext>
     <p:ext uri="{2D200454-40CA-4A62-9FC3-DE9A4176ACB9}">
-      <p15:notesGuideLst xmlns:p15="http://schemas.microsoft.com/office/powerpoint/2012/main"/>
+      <p15:notesGuideLst/>
     </p:ext>
   </p:extLst>
 </p:presentation>
-</file>
-
-<file path=ppt/handoutMasters/handoutMaster1.xml><?xml version="1.0" encoding="utf-8"?>
-<p:handoutMaster xmlns:a="http://schemas.openxmlformats.org/drawingml/2006/main" xmlns:r="http://schemas.openxmlformats.org/officeDocument/2006/relationships" xmlns:p="http://schemas.openxmlformats.org/presentationml/2006/main">
-  <p:cSld>
-    <p:bg>
-      <p:bgRef idx="1001">
-        <a:schemeClr val="bg1"/>
-      </p:bgRef>
-    </p:bg>
-    <p:spTree>
-      <p:nvGrpSpPr>
-        <p:cNvPr id="1" name=""/>
-        <p:cNvGrpSpPr/>
-        <p:nvPr/>
-      </p:nvGrpSpPr>
-      <p:grpSpPr>
-        <a:xfrm>
-          <a:off x="0" y="0"/>
-          <a:ext cx="0" cy="0"/>
-          <a:chOff x="0" y="0"/>
-          <a:chExt cx="0" cy="0"/>
-        </a:xfrm>
-      </p:grpSpPr>
-      <p:sp>
-        <p:nvSpPr>
-          <p:cNvPr id="2" name="Header Placeholder 1">
-            <a:extLst>
-              <a:ext uri="{FF2B5EF4-FFF2-40B4-BE49-F238E27FC236}">
-                <a16:creationId xmlns:a16="http://schemas.microsoft.com/office/drawing/2014/main" id="{93C2B20C-36DD-2C19-1A23-6E62AD88D937}"/>
-              </a:ext>
-            </a:extLst>
-          </p:cNvPr>
-          <p:cNvSpPr>
-            <a:spLocks noGrp="1"/>
-          </p:cNvSpPr>
-          <p:nvPr>
-            <p:ph type="hdr" sz="quarter"/>
-          </p:nvPr>
-        </p:nvSpPr>
-        <p:spPr>
-          <a:xfrm>
-            <a:off x="0" y="0"/>
-            <a:ext cx="2971800" cy="458788"/>
-          </a:xfrm>
-          <a:prstGeom prst="rect">
-            <a:avLst/>
-          </a:prstGeom>
-        </p:spPr>
-        <p:txBody>
-          <a:bodyPr vert="horz" lIns="91440" tIns="45720" rIns="91440" bIns="45720" rtlCol="0"/>
-          <a:lstStyle>
-            <a:lvl1pPr algn="l">
-              <a:defRPr sz="1200"/>
-            </a:lvl1pPr>
-          </a:lstStyle>
-          <a:p>
-            <a:endParaRPr lang="en-CA"/>
-          </a:p>
-        </p:txBody>
-      </p:sp>
-      <p:sp>
-        <p:nvSpPr>
-          <p:cNvPr id="3" name="Date Placeholder 2">
-            <a:extLst>
-              <a:ext uri="{FF2B5EF4-FFF2-40B4-BE49-F238E27FC236}">
-                <a16:creationId xmlns:a16="http://schemas.microsoft.com/office/drawing/2014/main" id="{47638C2A-FBC2-F826-4E47-515ACF0AAD70}"/>
-              </a:ext>
-            </a:extLst>
-          </p:cNvPr>
-          <p:cNvSpPr>
-            <a:spLocks noGrp="1"/>
-          </p:cNvSpPr>
-          <p:nvPr>
-            <p:ph type="dt" sz="quarter" idx="1"/>
-          </p:nvPr>
-        </p:nvSpPr>
-        <p:spPr>
-          <a:xfrm>
-            <a:off x="3884613" y="0"/>
-            <a:ext cx="2971800" cy="458788"/>
-          </a:xfrm>
-          <a:prstGeom prst="rect">
-            <a:avLst/>
-          </a:prstGeom>
-        </p:spPr>
-        <p:txBody>
-          <a:bodyPr vert="horz" lIns="91440" tIns="45720" rIns="91440" bIns="45720" rtlCol="0"/>
-          <a:lstStyle>
-            <a:lvl1pPr algn="r">
-              <a:defRPr sz="1200"/>
-            </a:lvl1pPr>
-          </a:lstStyle>
-          <a:p>
-            <a:fld id="{728AA843-2E0F-4143-82E9-3671A2E63393}" type="datetimeFigureOut">
-              <a:rPr lang="en-CA" smtClean="0"/>
-              <a:t>2024-02-25</a:t>
-            </a:fld>
-            <a:endParaRPr lang="en-CA"/>
-          </a:p>
-        </p:txBody>
-      </p:sp>
-      <p:sp>
-        <p:nvSpPr>
-          <p:cNvPr id="4" name="Footer Placeholder 3">
-            <a:extLst>
-              <a:ext uri="{FF2B5EF4-FFF2-40B4-BE49-F238E27FC236}">
-                <a16:creationId xmlns:a16="http://schemas.microsoft.com/office/drawing/2014/main" id="{0DAF3194-4F99-1E70-3E5D-BB45145B5E93}"/>
-              </a:ext>
-            </a:extLst>
-          </p:cNvPr>
-          <p:cNvSpPr>
-            <a:spLocks noGrp="1"/>
-          </p:cNvSpPr>
-          <p:nvPr>
-            <p:ph type="ftr" sz="quarter" idx="2"/>
-          </p:nvPr>
-        </p:nvSpPr>
-        <p:spPr>
-          <a:xfrm>
-            <a:off x="0" y="8685213"/>
-            <a:ext cx="2971800" cy="458787"/>
-          </a:xfrm>
-          <a:prstGeom prst="rect">
-            <a:avLst/>
-          </a:prstGeom>
-        </p:spPr>
-        <p:txBody>
-          <a:bodyPr vert="horz" lIns="91440" tIns="45720" rIns="91440" bIns="45720" rtlCol="0" anchor="b"/>
-          <a:lstStyle>
-            <a:lvl1pPr algn="l">
-              <a:defRPr sz="1200"/>
-            </a:lvl1pPr>
-          </a:lstStyle>
-          <a:p>
-            <a:endParaRPr lang="en-CA"/>
-          </a:p>
-        </p:txBody>
-      </p:sp>
-      <p:sp>
-        <p:nvSpPr>
-          <p:cNvPr id="5" name="Slide Number Placeholder 4">
-            <a:extLst>
-              <a:ext uri="{FF2B5EF4-FFF2-40B4-BE49-F238E27FC236}">
-                <a16:creationId xmlns:a16="http://schemas.microsoft.com/office/drawing/2014/main" id="{F395F607-5982-1F4E-92A4-A3BDA7B576C1}"/>
-              </a:ext>
-            </a:extLst>
-          </p:cNvPr>
-          <p:cNvSpPr>
-            <a:spLocks noGrp="1"/>
-          </p:cNvSpPr>
-          <p:nvPr>
-            <p:ph type="sldNum" sz="quarter" idx="3"/>
-          </p:nvPr>
-        </p:nvSpPr>
-        <p:spPr>
-          <a:xfrm>
-            <a:off x="3884613" y="8685213"/>
-            <a:ext cx="2971800" cy="458787"/>
-          </a:xfrm>
-          <a:prstGeom prst="rect">
-            <a:avLst/>
-          </a:prstGeom>
-        </p:spPr>
-        <p:txBody>
-          <a:bodyPr vert="horz" lIns="91440" tIns="45720" rIns="91440" bIns="45720" rtlCol="0" anchor="b"/>
-          <a:lstStyle>
-            <a:lvl1pPr algn="r">
-              <a:defRPr sz="1200"/>
-            </a:lvl1pPr>
-          </a:lstStyle>
-          <a:p>
-            <a:fld id="{F9A60F49-0132-794E-B410-7BFB28AC3F02}" type="slidenum">
-              <a:rPr lang="en-CA" smtClean="0"/>
-              <a:t>‹#›</a:t>
-            </a:fld>
-            <a:endParaRPr lang="en-CA"/>
-          </a:p>
-        </p:txBody>
-      </p:sp>
-    </p:spTree>
-    <p:extLst>
-      <p:ext uri="{BB962C8B-B14F-4D97-AF65-F5344CB8AC3E}">
-        <p14:creationId xmlns:p14="http://schemas.microsoft.com/office/powerpoint/2010/main" val="2854789273"/>
-      </p:ext>
-    </p:extLst>
-  </p:cSld>
-  <p:clrMap bg1="lt1" tx1="dk1" bg2="lt2" tx2="dk2" accent1="accent1" accent2="accent2" accent3="accent3" accent4="accent4" accent5="accent5" accent6="accent6" hlink="hlink" folHlink="folHlink"/>
-</p:handoutMaster>
 </file>
 
 <file path=ppt/slideLayouts/slideLayout1.xml><?xml version="1.0" encoding="utf-8"?>
@@ -1088,8 +896,8 @@
         </p:nvSpPr>
         <p:spPr>
           <a:xfrm>
-            <a:off x="359999" y="601475"/>
-            <a:ext cx="4306593" cy="5655050"/>
+            <a:off x="838200" y="365125"/>
+            <a:ext cx="10515600" cy="900000"/>
           </a:xfrm>
           <a:noFill/>
         </p:spPr>
@@ -1129,8 +937,8 @@
         </p:nvSpPr>
         <p:spPr>
           <a:xfrm>
-            <a:off x="4666592" y="601475"/>
-            <a:ext cx="7165509" cy="5655600"/>
+            <a:off x="838200" y="1400000"/>
+            <a:ext cx="10515600" cy="4600000"/>
           </a:xfrm>
         </p:spPr>
         <p:txBody>
@@ -3943,7 +3751,7 @@
         <a:defRPr lang="en-US"/>
       </a:defPPr>
       <a:lvl1pPr marL="0" algn="l" defTabSz="914400" rtl="0" eaLnBrk="1" latinLnBrk="0" hangingPunct="1">
-        <a:defRPr sz="1800" kern="1200">
+        <a:defRPr sz="1400" kern="1200">
           <a:solidFill>
             <a:schemeClr val="tx1"/>
           </a:solidFill>
@@ -3953,7 +3761,7 @@
         </a:defRPr>
       </a:lvl1pPr>
       <a:lvl2pPr marL="457200" algn="l" defTabSz="914400" rtl="0" eaLnBrk="1" latinLnBrk="0" hangingPunct="1">
-        <a:defRPr sz="1800" kern="1200">
+        <a:defRPr sz="1400" kern="1200">
           <a:solidFill>
             <a:schemeClr val="tx1"/>
           </a:solidFill>
@@ -3963,7 +3771,7 @@
         </a:defRPr>
       </a:lvl2pPr>
       <a:lvl3pPr marL="914400" algn="l" defTabSz="914400" rtl="0" eaLnBrk="1" latinLnBrk="0" hangingPunct="1">
-        <a:defRPr sz="1800" kern="1200">
+        <a:defRPr sz="1400" kern="1200">
           <a:solidFill>
             <a:schemeClr val="tx1"/>
           </a:solidFill>
@@ -3973,7 +3781,7 @@
         </a:defRPr>
       </a:lvl3pPr>
       <a:lvl4pPr marL="1371600" algn="l" defTabSz="914400" rtl="0" eaLnBrk="1" latinLnBrk="0" hangingPunct="1">
-        <a:defRPr sz="1800" kern="1200">
+        <a:defRPr sz="1400" kern="1200">
           <a:solidFill>
             <a:schemeClr val="tx1"/>
           </a:solidFill>
@@ -3983,7 +3791,7 @@
         </a:defRPr>
       </a:lvl4pPr>
       <a:lvl5pPr marL="1828800" algn="l" defTabSz="914400" rtl="0" eaLnBrk="1" latinLnBrk="0" hangingPunct="1">
-        <a:defRPr sz="1800" kern="1200">
+        <a:defRPr sz="1400" kern="1200">
           <a:solidFill>
             <a:schemeClr val="tx1"/>
           </a:solidFill>
@@ -3993,7 +3801,7 @@
         </a:defRPr>
       </a:lvl5pPr>
       <a:lvl6pPr marL="2286000" algn="l" defTabSz="914400" rtl="0" eaLnBrk="1" latinLnBrk="0" hangingPunct="1">
-        <a:defRPr sz="1800" kern="1200">
+        <a:defRPr sz="1400" kern="1200">
           <a:solidFill>
             <a:schemeClr val="tx1"/>
           </a:solidFill>
@@ -4003,7 +3811,7 @@
         </a:defRPr>
       </a:lvl6pPr>
       <a:lvl7pPr marL="2743200" algn="l" defTabSz="914400" rtl="0" eaLnBrk="1" latinLnBrk="0" hangingPunct="1">
-        <a:defRPr sz="1800" kern="1200">
+        <a:defRPr sz="1400" kern="1200">
           <a:solidFill>
             <a:schemeClr val="tx1"/>
           </a:solidFill>
@@ -4013,7 +3821,7 @@
         </a:defRPr>
       </a:lvl7pPr>
       <a:lvl8pPr marL="3200400" algn="l" defTabSz="914400" rtl="0" eaLnBrk="1" latinLnBrk="0" hangingPunct="1">
-        <a:defRPr sz="1800" kern="1200">
+        <a:defRPr sz="1400" kern="1200">
           <a:solidFill>
             <a:schemeClr val="tx1"/>
           </a:solidFill>
@@ -4023,7 +3831,7 @@
         </a:defRPr>
       </a:lvl8pPr>
       <a:lvl9pPr marL="3657600" algn="l" defTabSz="914400" rtl="0" eaLnBrk="1" latinLnBrk="0" hangingPunct="1">
-        <a:defRPr sz="1800" kern="1200">
+        <a:defRPr sz="1400" kern="1200">
           <a:solidFill>
             <a:schemeClr val="tx1"/>
           </a:solidFill>

</xml_diff>